<commit_message>
docs: sync pitch deck — Phase 1 completed features, WorldCover layer, live GIS pipeline
</commit_message>
<xml_diff>
--- a/AeroThermal_SIH26162_Official_Pitch.pptx
+++ b/AeroThermal_SIH26162_Official_Pitch.pptx
@@ -5,15 +5,15 @@
     <p:sldMasterId id="2147483648" r:id="rId1"/>
   </p:sldMasterIdLst>
   <p:sldIdLst>
-    <p:sldId id="256" r:id="rId7"/>
-    <p:sldId id="257" r:id="rId8"/>
-    <p:sldId id="258" r:id="rId9"/>
-    <p:sldId id="259" r:id="rId10"/>
-    <p:sldId id="260" r:id="rId11"/>
-    <p:sldId id="261" r:id="rId12"/>
-    <p:sldId id="262" r:id="rId13"/>
+    <p:sldId id="256" r:id="rId2"/>
+    <p:sldId id="257" r:id="rId3"/>
+    <p:sldId id="258" r:id="rId4"/>
+    <p:sldId id="259" r:id="rId5"/>
+    <p:sldId id="260" r:id="rId6"/>
+    <p:sldId id="261" r:id="rId7"/>
+    <p:sldId id="262" r:id="rId8"/>
   </p:sldIdLst>
-  <p:sldSz cx="12191695" cy="6858000" type="screen4x3"/>
+  <p:sldSz cx="12192000" cy="6858000"/>
   <p:notesSz cx="6858000" cy="9144000"/>
   <p:defaultTextStyle>
     <a:defPPr>
@@ -110,6 +110,22 @@
       </a:defRPr>
     </a:lvl9pPr>
   </p:defaultTextStyle>
+  <p:extLst>
+    <p:ext uri="{EFAFB233-063F-42B5-8137-9DF3F51BA10A}">
+      <p15:sldGuideLst xmlns:p15="http://schemas.microsoft.com/office/powerpoint/2012/main">
+        <p15:guide id="1" orient="horz" pos="2160">
+          <p15:clr>
+            <a:srgbClr val="A4A3A4"/>
+          </p15:clr>
+        </p15:guide>
+        <p15:guide id="2" pos="2880">
+          <p15:clr>
+            <a:srgbClr val="A4A3A4"/>
+          </p15:clr>
+        </p15:guide>
+      </p15:sldGuideLst>
+    </p:ext>
+  </p:extLst>
 </p:presentation>
 </file>
 
@@ -151,10 +167,9 @@
           <a:lstStyle/>
           <a:p>
             <a:r>
-              <a:rPr lang="en-US" smtClean="0"/>
+              <a:rPr lang="en-US"/>
               <a:t>Click to edit Master title style</a:t>
             </a:r>
-            <a:endParaRPr lang="en-US"/>
           </a:p>
         </p:txBody>
       </p:sp>
@@ -270,10 +285,9 @@
           </a:lstStyle>
           <a:p>
             <a:r>
-              <a:rPr lang="en-US" smtClean="0"/>
+              <a:rPr lang="en-US"/>
               <a:t>Click to edit Master subtitle style</a:t>
             </a:r>
-            <a:endParaRPr lang="en-US"/>
           </a:p>
         </p:txBody>
       </p:sp>
@@ -294,7 +308,7 @@
           <a:p>
             <a:fld id="{5BCAD085-E8A6-8845-BD4E-CB4CCA059FC4}" type="datetimeFigureOut">
               <a:rPr lang="en-US" smtClean="0"/>
-              <a:t>1/27/13</a:t>
+              <a:t>9/4/2026</a:t>
             </a:fld>
             <a:endParaRPr lang="en-US"/>
           </a:p>
@@ -388,10 +402,9 @@
           <a:lstStyle/>
           <a:p>
             <a:r>
-              <a:rPr lang="en-US" smtClean="0"/>
+              <a:rPr lang="en-US"/>
               <a:t>Click to edit Master title style</a:t>
             </a:r>
-            <a:endParaRPr lang="en-US"/>
           </a:p>
         </p:txBody>
       </p:sp>
@@ -412,38 +425,37 @@
           <a:p>
             <a:pPr lvl="0"/>
             <a:r>
-              <a:rPr lang="en-US" smtClean="0"/>
+              <a:rPr lang="en-US"/>
               <a:t>Click to edit Master text styles</a:t>
             </a:r>
           </a:p>
           <a:p>
             <a:pPr lvl="1"/>
             <a:r>
-              <a:rPr lang="en-US" smtClean="0"/>
+              <a:rPr lang="en-US"/>
               <a:t>Second level</a:t>
             </a:r>
           </a:p>
           <a:p>
             <a:pPr lvl="2"/>
             <a:r>
-              <a:rPr lang="en-US" smtClean="0"/>
+              <a:rPr lang="en-US"/>
               <a:t>Third level</a:t>
             </a:r>
           </a:p>
           <a:p>
             <a:pPr lvl="3"/>
             <a:r>
-              <a:rPr lang="en-US" smtClean="0"/>
+              <a:rPr lang="en-US"/>
               <a:t>Fourth level</a:t>
             </a:r>
           </a:p>
           <a:p>
             <a:pPr lvl="4"/>
             <a:r>
-              <a:rPr lang="en-US" smtClean="0"/>
+              <a:rPr lang="en-US"/>
               <a:t>Fifth level</a:t>
             </a:r>
-            <a:endParaRPr lang="en-US"/>
           </a:p>
         </p:txBody>
       </p:sp>
@@ -464,7 +476,7 @@
           <a:p>
             <a:fld id="{5BCAD085-E8A6-8845-BD4E-CB4CCA059FC4}" type="datetimeFigureOut">
               <a:rPr lang="en-US" smtClean="0"/>
-              <a:t>1/27/13</a:t>
+              <a:t>9/4/2026</a:t>
             </a:fld>
             <a:endParaRPr lang="en-US"/>
           </a:p>
@@ -563,10 +575,9 @@
           <a:lstStyle/>
           <a:p>
             <a:r>
-              <a:rPr lang="en-US" smtClean="0"/>
+              <a:rPr lang="en-US"/>
               <a:t>Click to edit Master title style</a:t>
             </a:r>
-            <a:endParaRPr lang="en-US"/>
           </a:p>
         </p:txBody>
       </p:sp>
@@ -592,38 +603,37 @@
           <a:p>
             <a:pPr lvl="0"/>
             <a:r>
-              <a:rPr lang="en-US" smtClean="0"/>
+              <a:rPr lang="en-US"/>
               <a:t>Click to edit Master text styles</a:t>
             </a:r>
           </a:p>
           <a:p>
             <a:pPr lvl="1"/>
             <a:r>
-              <a:rPr lang="en-US" smtClean="0"/>
+              <a:rPr lang="en-US"/>
               <a:t>Second level</a:t>
             </a:r>
           </a:p>
           <a:p>
             <a:pPr lvl="2"/>
             <a:r>
-              <a:rPr lang="en-US" smtClean="0"/>
+              <a:rPr lang="en-US"/>
               <a:t>Third level</a:t>
             </a:r>
           </a:p>
           <a:p>
             <a:pPr lvl="3"/>
             <a:r>
-              <a:rPr lang="en-US" smtClean="0"/>
+              <a:rPr lang="en-US"/>
               <a:t>Fourth level</a:t>
             </a:r>
           </a:p>
           <a:p>
             <a:pPr lvl="4"/>
             <a:r>
-              <a:rPr lang="en-US" smtClean="0"/>
+              <a:rPr lang="en-US"/>
               <a:t>Fifth level</a:t>
             </a:r>
-            <a:endParaRPr lang="en-US"/>
           </a:p>
         </p:txBody>
       </p:sp>
@@ -644,7 +654,7 @@
           <a:p>
             <a:fld id="{5BCAD085-E8A6-8845-BD4E-CB4CCA059FC4}" type="datetimeFigureOut">
               <a:rPr lang="en-US" smtClean="0"/>
-              <a:t>1/27/13</a:t>
+              <a:t>9/4/2026</a:t>
             </a:fld>
             <a:endParaRPr lang="en-US"/>
           </a:p>
@@ -738,10 +748,9 @@
           <a:lstStyle/>
           <a:p>
             <a:r>
-              <a:rPr lang="en-US" smtClean="0"/>
+              <a:rPr lang="en-US"/>
               <a:t>Click to edit Master title style</a:t>
             </a:r>
-            <a:endParaRPr lang="en-US"/>
           </a:p>
         </p:txBody>
       </p:sp>
@@ -762,38 +771,37 @@
           <a:p>
             <a:pPr lvl="0"/>
             <a:r>
-              <a:rPr lang="en-US" smtClean="0"/>
+              <a:rPr lang="en-US"/>
               <a:t>Click to edit Master text styles</a:t>
             </a:r>
           </a:p>
           <a:p>
             <a:pPr lvl="1"/>
             <a:r>
-              <a:rPr lang="en-US" smtClean="0"/>
+              <a:rPr lang="en-US"/>
               <a:t>Second level</a:t>
             </a:r>
           </a:p>
           <a:p>
             <a:pPr lvl="2"/>
             <a:r>
-              <a:rPr lang="en-US" smtClean="0"/>
+              <a:rPr lang="en-US"/>
               <a:t>Third level</a:t>
             </a:r>
           </a:p>
           <a:p>
             <a:pPr lvl="3"/>
             <a:r>
-              <a:rPr lang="en-US" smtClean="0"/>
+              <a:rPr lang="en-US"/>
               <a:t>Fourth level</a:t>
             </a:r>
           </a:p>
           <a:p>
             <a:pPr lvl="4"/>
             <a:r>
-              <a:rPr lang="en-US" smtClean="0"/>
+              <a:rPr lang="en-US"/>
               <a:t>Fifth level</a:t>
             </a:r>
-            <a:endParaRPr lang="en-US"/>
           </a:p>
         </p:txBody>
       </p:sp>
@@ -814,7 +822,7 @@
           <a:p>
             <a:fld id="{5BCAD085-E8A6-8845-BD4E-CB4CCA059FC4}" type="datetimeFigureOut">
               <a:rPr lang="en-US" smtClean="0"/>
-              <a:t>1/27/13</a:t>
+              <a:t>9/4/2026</a:t>
             </a:fld>
             <a:endParaRPr lang="en-US"/>
           </a:p>
@@ -917,10 +925,9 @@
           </a:lstStyle>
           <a:p>
             <a:r>
-              <a:rPr lang="en-US" smtClean="0"/>
+              <a:rPr lang="en-US"/>
               <a:t>Click to edit Master title style</a:t>
             </a:r>
-            <a:endParaRPr lang="en-US"/>
           </a:p>
         </p:txBody>
       </p:sp>
@@ -1037,7 +1044,7 @@
           <a:p>
             <a:pPr lvl="0"/>
             <a:r>
-              <a:rPr lang="en-US" smtClean="0"/>
+              <a:rPr lang="en-US"/>
               <a:t>Click to edit Master text styles</a:t>
             </a:r>
           </a:p>
@@ -1060,7 +1067,7 @@
           <a:p>
             <a:fld id="{5BCAD085-E8A6-8845-BD4E-CB4CCA059FC4}" type="datetimeFigureOut">
               <a:rPr lang="en-US" smtClean="0"/>
-              <a:t>1/27/13</a:t>
+              <a:t>9/4/2026</a:t>
             </a:fld>
             <a:endParaRPr lang="en-US"/>
           </a:p>
@@ -1154,10 +1161,9 @@
           <a:lstStyle/>
           <a:p>
             <a:r>
-              <a:rPr lang="en-US" smtClean="0"/>
+              <a:rPr lang="en-US"/>
               <a:t>Click to edit Master title style</a:t>
             </a:r>
-            <a:endParaRPr lang="en-US"/>
           </a:p>
         </p:txBody>
       </p:sp>
@@ -1211,38 +1217,37 @@
           <a:p>
             <a:pPr lvl="0"/>
             <a:r>
-              <a:rPr lang="en-US" smtClean="0"/>
+              <a:rPr lang="en-US"/>
               <a:t>Click to edit Master text styles</a:t>
             </a:r>
           </a:p>
           <a:p>
             <a:pPr lvl="1"/>
             <a:r>
-              <a:rPr lang="en-US" smtClean="0"/>
+              <a:rPr lang="en-US"/>
               <a:t>Second level</a:t>
             </a:r>
           </a:p>
           <a:p>
             <a:pPr lvl="2"/>
             <a:r>
-              <a:rPr lang="en-US" smtClean="0"/>
+              <a:rPr lang="en-US"/>
               <a:t>Third level</a:t>
             </a:r>
           </a:p>
           <a:p>
             <a:pPr lvl="3"/>
             <a:r>
-              <a:rPr lang="en-US" smtClean="0"/>
+              <a:rPr lang="en-US"/>
               <a:t>Fourth level</a:t>
             </a:r>
           </a:p>
           <a:p>
             <a:pPr lvl="4"/>
             <a:r>
-              <a:rPr lang="en-US" smtClean="0"/>
+              <a:rPr lang="en-US"/>
               <a:t>Fifth level</a:t>
             </a:r>
-            <a:endParaRPr lang="en-US"/>
           </a:p>
         </p:txBody>
       </p:sp>
@@ -1296,38 +1301,37 @@
           <a:p>
             <a:pPr lvl="0"/>
             <a:r>
-              <a:rPr lang="en-US" smtClean="0"/>
+              <a:rPr lang="en-US"/>
               <a:t>Click to edit Master text styles</a:t>
             </a:r>
           </a:p>
           <a:p>
             <a:pPr lvl="1"/>
             <a:r>
-              <a:rPr lang="en-US" smtClean="0"/>
+              <a:rPr lang="en-US"/>
               <a:t>Second level</a:t>
             </a:r>
           </a:p>
           <a:p>
             <a:pPr lvl="2"/>
             <a:r>
-              <a:rPr lang="en-US" smtClean="0"/>
+              <a:rPr lang="en-US"/>
               <a:t>Third level</a:t>
             </a:r>
           </a:p>
           <a:p>
             <a:pPr lvl="3"/>
             <a:r>
-              <a:rPr lang="en-US" smtClean="0"/>
+              <a:rPr lang="en-US"/>
               <a:t>Fourth level</a:t>
             </a:r>
           </a:p>
           <a:p>
             <a:pPr lvl="4"/>
             <a:r>
-              <a:rPr lang="en-US" smtClean="0"/>
+              <a:rPr lang="en-US"/>
               <a:t>Fifth level</a:t>
             </a:r>
-            <a:endParaRPr lang="en-US"/>
           </a:p>
         </p:txBody>
       </p:sp>
@@ -1348,7 +1352,7 @@
           <a:p>
             <a:fld id="{5BCAD085-E8A6-8845-BD4E-CB4CCA059FC4}" type="datetimeFigureOut">
               <a:rPr lang="en-US" smtClean="0"/>
-              <a:t>1/27/13</a:t>
+              <a:t>9/4/2026</a:t>
             </a:fld>
             <a:endParaRPr lang="en-US"/>
           </a:p>
@@ -1446,10 +1450,9 @@
           </a:lstStyle>
           <a:p>
             <a:r>
-              <a:rPr lang="en-US" smtClean="0"/>
+              <a:rPr lang="en-US"/>
               <a:t>Click to edit Master title style</a:t>
             </a:r>
-            <a:endParaRPr lang="en-US"/>
           </a:p>
         </p:txBody>
       </p:sp>
@@ -1512,7 +1515,7 @@
           <a:p>
             <a:pPr lvl="0"/>
             <a:r>
-              <a:rPr lang="en-US" smtClean="0"/>
+              <a:rPr lang="en-US"/>
               <a:t>Click to edit Master text styles</a:t>
             </a:r>
           </a:p>
@@ -1568,38 +1571,37 @@
           <a:p>
             <a:pPr lvl="0"/>
             <a:r>
-              <a:rPr lang="en-US" smtClean="0"/>
+              <a:rPr lang="en-US"/>
               <a:t>Click to edit Master text styles</a:t>
             </a:r>
           </a:p>
           <a:p>
             <a:pPr lvl="1"/>
             <a:r>
-              <a:rPr lang="en-US" smtClean="0"/>
+              <a:rPr lang="en-US"/>
               <a:t>Second level</a:t>
             </a:r>
           </a:p>
           <a:p>
             <a:pPr lvl="2"/>
             <a:r>
-              <a:rPr lang="en-US" smtClean="0"/>
+              <a:rPr lang="en-US"/>
               <a:t>Third level</a:t>
             </a:r>
           </a:p>
           <a:p>
             <a:pPr lvl="3"/>
             <a:r>
-              <a:rPr lang="en-US" smtClean="0"/>
+              <a:rPr lang="en-US"/>
               <a:t>Fourth level</a:t>
             </a:r>
           </a:p>
           <a:p>
             <a:pPr lvl="4"/>
             <a:r>
-              <a:rPr lang="en-US" smtClean="0"/>
+              <a:rPr lang="en-US"/>
               <a:t>Fifth level</a:t>
             </a:r>
-            <a:endParaRPr lang="en-US"/>
           </a:p>
         </p:txBody>
       </p:sp>
@@ -1662,7 +1664,7 @@
           <a:p>
             <a:pPr lvl="0"/>
             <a:r>
-              <a:rPr lang="en-US" smtClean="0"/>
+              <a:rPr lang="en-US"/>
               <a:t>Click to edit Master text styles</a:t>
             </a:r>
           </a:p>
@@ -1718,38 +1720,37 @@
           <a:p>
             <a:pPr lvl="0"/>
             <a:r>
-              <a:rPr lang="en-US" smtClean="0"/>
+              <a:rPr lang="en-US"/>
               <a:t>Click to edit Master text styles</a:t>
             </a:r>
           </a:p>
           <a:p>
             <a:pPr lvl="1"/>
             <a:r>
-              <a:rPr lang="en-US" smtClean="0"/>
+              <a:rPr lang="en-US"/>
               <a:t>Second level</a:t>
             </a:r>
           </a:p>
           <a:p>
             <a:pPr lvl="2"/>
             <a:r>
-              <a:rPr lang="en-US" smtClean="0"/>
+              <a:rPr lang="en-US"/>
               <a:t>Third level</a:t>
             </a:r>
           </a:p>
           <a:p>
             <a:pPr lvl="3"/>
             <a:r>
-              <a:rPr lang="en-US" smtClean="0"/>
+              <a:rPr lang="en-US"/>
               <a:t>Fourth level</a:t>
             </a:r>
           </a:p>
           <a:p>
             <a:pPr lvl="4"/>
             <a:r>
-              <a:rPr lang="en-US" smtClean="0"/>
+              <a:rPr lang="en-US"/>
               <a:t>Fifth level</a:t>
             </a:r>
-            <a:endParaRPr lang="en-US"/>
           </a:p>
         </p:txBody>
       </p:sp>
@@ -1770,7 +1771,7 @@
           <a:p>
             <a:fld id="{5BCAD085-E8A6-8845-BD4E-CB4CCA059FC4}" type="datetimeFigureOut">
               <a:rPr lang="en-US" smtClean="0"/>
-              <a:t>1/27/13</a:t>
+              <a:t>9/4/2026</a:t>
             </a:fld>
             <a:endParaRPr lang="en-US"/>
           </a:p>
@@ -1864,10 +1865,9 @@
           <a:lstStyle/>
           <a:p>
             <a:r>
-              <a:rPr lang="en-US" smtClean="0"/>
+              <a:rPr lang="en-US"/>
               <a:t>Click to edit Master title style</a:t>
             </a:r>
-            <a:endParaRPr lang="en-US"/>
           </a:p>
         </p:txBody>
       </p:sp>
@@ -1888,7 +1888,7 @@
           <a:p>
             <a:fld id="{5BCAD085-E8A6-8845-BD4E-CB4CCA059FC4}" type="datetimeFigureOut">
               <a:rPr lang="en-US" smtClean="0"/>
-              <a:t>1/27/13</a:t>
+              <a:t>9/4/2026</a:t>
             </a:fld>
             <a:endParaRPr lang="en-US"/>
           </a:p>
@@ -1983,7 +1983,7 @@
           <a:p>
             <a:fld id="{5BCAD085-E8A6-8845-BD4E-CB4CCA059FC4}" type="datetimeFigureOut">
               <a:rPr lang="en-US" smtClean="0"/>
-              <a:t>1/27/13</a:t>
+              <a:t>9/4/2026</a:t>
             </a:fld>
             <a:endParaRPr lang="en-US"/>
           </a:p>
@@ -2086,10 +2086,9 @@
           </a:lstStyle>
           <a:p>
             <a:r>
-              <a:rPr lang="en-US" smtClean="0"/>
+              <a:rPr lang="en-US"/>
               <a:t>Click to edit Master title style</a:t>
             </a:r>
-            <a:endParaRPr lang="en-US"/>
           </a:p>
         </p:txBody>
       </p:sp>
@@ -2143,38 +2142,37 @@
           <a:p>
             <a:pPr lvl="0"/>
             <a:r>
-              <a:rPr lang="en-US" smtClean="0"/>
+              <a:rPr lang="en-US"/>
               <a:t>Click to edit Master text styles</a:t>
             </a:r>
           </a:p>
           <a:p>
             <a:pPr lvl="1"/>
             <a:r>
-              <a:rPr lang="en-US" smtClean="0"/>
+              <a:rPr lang="en-US"/>
               <a:t>Second level</a:t>
             </a:r>
           </a:p>
           <a:p>
             <a:pPr lvl="2"/>
             <a:r>
-              <a:rPr lang="en-US" smtClean="0"/>
+              <a:rPr lang="en-US"/>
               <a:t>Third level</a:t>
             </a:r>
           </a:p>
           <a:p>
             <a:pPr lvl="3"/>
             <a:r>
-              <a:rPr lang="en-US" smtClean="0"/>
+              <a:rPr lang="en-US"/>
               <a:t>Fourth level</a:t>
             </a:r>
           </a:p>
           <a:p>
             <a:pPr lvl="4"/>
             <a:r>
-              <a:rPr lang="en-US" smtClean="0"/>
+              <a:rPr lang="en-US"/>
               <a:t>Fifth level</a:t>
             </a:r>
-            <a:endParaRPr lang="en-US"/>
           </a:p>
         </p:txBody>
       </p:sp>
@@ -2237,7 +2235,7 @@
           <a:p>
             <a:pPr lvl="0"/>
             <a:r>
-              <a:rPr lang="en-US" smtClean="0"/>
+              <a:rPr lang="en-US"/>
               <a:t>Click to edit Master text styles</a:t>
             </a:r>
           </a:p>
@@ -2260,7 +2258,7 @@
           <a:p>
             <a:fld id="{5BCAD085-E8A6-8845-BD4E-CB4CCA059FC4}" type="datetimeFigureOut">
               <a:rPr lang="en-US" smtClean="0"/>
-              <a:t>1/27/13</a:t>
+              <a:t>9/4/2026</a:t>
             </a:fld>
             <a:endParaRPr lang="en-US"/>
           </a:p>
@@ -2363,10 +2361,9 @@
           </a:lstStyle>
           <a:p>
             <a:r>
-              <a:rPr lang="en-US" smtClean="0"/>
+              <a:rPr lang="en-US"/>
               <a:t>Click to edit Master title style</a:t>
             </a:r>
-            <a:endParaRPr lang="en-US"/>
           </a:p>
         </p:txBody>
       </p:sp>
@@ -2490,7 +2487,7 @@
           <a:p>
             <a:pPr lvl="0"/>
             <a:r>
-              <a:rPr lang="en-US" smtClean="0"/>
+              <a:rPr lang="en-US"/>
               <a:t>Click to edit Master text styles</a:t>
             </a:r>
           </a:p>
@@ -2513,7 +2510,7 @@
           <a:p>
             <a:fld id="{5BCAD085-E8A6-8845-BD4E-CB4CCA059FC4}" type="datetimeFigureOut">
               <a:rPr lang="en-US" smtClean="0"/>
-              <a:t>1/27/13</a:t>
+              <a:t>9/4/2026</a:t>
             </a:fld>
             <a:endParaRPr lang="en-US"/>
           </a:p>
@@ -2622,10 +2619,9 @@
           <a:lstStyle/>
           <a:p>
             <a:r>
-              <a:rPr lang="en-US" smtClean="0"/>
+              <a:rPr lang="en-US"/>
               <a:t>Click to edit Master title style</a:t>
             </a:r>
-            <a:endParaRPr lang="en-US"/>
           </a:p>
         </p:txBody>
       </p:sp>
@@ -2656,38 +2652,37 @@
           <a:p>
             <a:pPr lvl="0"/>
             <a:r>
-              <a:rPr lang="en-US" smtClean="0"/>
+              <a:rPr lang="en-US"/>
               <a:t>Click to edit Master text styles</a:t>
             </a:r>
           </a:p>
           <a:p>
             <a:pPr lvl="1"/>
             <a:r>
-              <a:rPr lang="en-US" smtClean="0"/>
+              <a:rPr lang="en-US"/>
               <a:t>Second level</a:t>
             </a:r>
           </a:p>
           <a:p>
             <a:pPr lvl="2"/>
             <a:r>
-              <a:rPr lang="en-US" smtClean="0"/>
+              <a:rPr lang="en-US"/>
               <a:t>Third level</a:t>
             </a:r>
           </a:p>
           <a:p>
             <a:pPr lvl="3"/>
             <a:r>
-              <a:rPr lang="en-US" smtClean="0"/>
+              <a:rPr lang="en-US"/>
               <a:t>Fourth level</a:t>
             </a:r>
           </a:p>
           <a:p>
             <a:pPr lvl="4"/>
             <a:r>
-              <a:rPr lang="en-US" smtClean="0"/>
+              <a:rPr lang="en-US"/>
               <a:t>Fifth level</a:t>
             </a:r>
-            <a:endParaRPr lang="en-US"/>
           </a:p>
         </p:txBody>
       </p:sp>
@@ -2726,7 +2721,7 @@
           <a:p>
             <a:fld id="{5BCAD085-E8A6-8845-BD4E-CB4CCA059FC4}" type="datetimeFigureOut">
               <a:rPr lang="en-US" smtClean="0"/>
-              <a:t>1/27/13</a:t>
+              <a:t>9/4/2026</a:t>
             </a:fld>
             <a:endParaRPr lang="en-US"/>
           </a:p>
@@ -3085,7 +3080,7 @@
 </file>
 
 <file path=ppt/slides/slide1.xml><?xml version="1.0" encoding="utf-8"?>
-<p:sld xmlns:a="http://schemas.openxmlformats.org/drawingml/2006/main" xmlns:p="http://schemas.openxmlformats.org/presentationml/2006/main" xmlns:r="http://schemas.openxmlformats.org/officeDocument/2006/relationships">
+<p:sld xmlns:a="http://schemas.openxmlformats.org/drawingml/2006/main" xmlns:r="http://schemas.openxmlformats.org/officeDocument/2006/relationships" xmlns:p="http://schemas.openxmlformats.org/presentationml/2006/main">
   <p:cSld>
     <p:spTree>
       <p:nvGrpSpPr>
@@ -3093,7 +3088,14 @@
         <p:cNvGrpSpPr/>
         <p:nvPr/>
       </p:nvGrpSpPr>
-      <p:grpSpPr/>
+      <p:grpSpPr>
+        <a:xfrm>
+          <a:off x="0" y="0"/>
+          <a:ext cx="0" cy="0"/>
+          <a:chOff x="0" y="0"/>
+          <a:chExt cx="0" cy="0"/>
+        </a:xfrm>
+      </p:grpSpPr>
       <p:sp>
         <p:nvSpPr>
           <p:cNvPr id="2" name="Rectangle 1"/>
@@ -3134,6 +3136,7 @@
           <a:lstStyle/>
           <a:p>
             <a:pPr algn="ctr"/>
+            <a:endParaRPr/>
           </a:p>
         </p:txBody>
       </p:sp>
@@ -3177,6 +3180,7 @@
           <a:lstStyle/>
           <a:p>
             <a:pPr algn="ctr"/>
+            <a:endParaRPr/>
           </a:p>
         </p:txBody>
       </p:sp>
@@ -3373,11 +3377,11 @@
           </a:fontRef>
         </p:style>
         <p:txBody>
-          <a:bodyPr rtlCol="0" anchor="ctr" lIns="274320" tIns="274320" wrap="square"/>
+          <a:bodyPr wrap="square" lIns="274320" tIns="274320" rtlCol="0" anchor="ctr"/>
           <a:lstStyle/>
           <a:p>
             <a:pPr algn="ctr">
-              <a:defRPr b="1" sz="1200">
+              <a:defRPr sz="1200" b="1">
                 <a:solidFill>
                   <a:srgbClr val="06B6D4"/>
                 </a:solidFill>
@@ -3487,11 +3491,11 @@
           </a:fontRef>
         </p:style>
         <p:txBody>
-          <a:bodyPr rtlCol="0" anchor="ctr" lIns="274320" tIns="274320" wrap="square"/>
+          <a:bodyPr wrap="square" lIns="274320" tIns="274320" rtlCol="0" anchor="ctr"/>
           <a:lstStyle/>
           <a:p>
             <a:pPr algn="ctr">
-              <a:defRPr b="1" sz="1200">
+              <a:defRPr sz="1200" b="1">
                 <a:solidFill>
                   <a:srgbClr val="F97316"/>
                 </a:solidFill>
@@ -3503,7 +3507,7 @@
           </a:p>
           <a:p>
             <a:pPr>
-              <a:defRPr b="1" sz="1100">
+              <a:defRPr sz="1100" b="1">
                 <a:solidFill>
                   <a:srgbClr val="F8FAFC"/>
                 </a:solidFill>
@@ -3596,7 +3600,7 @@
 </file>
 
 <file path=ppt/slides/slide2.xml><?xml version="1.0" encoding="utf-8"?>
-<p:sld xmlns:a="http://schemas.openxmlformats.org/drawingml/2006/main" xmlns:p="http://schemas.openxmlformats.org/presentationml/2006/main" xmlns:r="http://schemas.openxmlformats.org/officeDocument/2006/relationships">
+<p:sld xmlns:a="http://schemas.openxmlformats.org/drawingml/2006/main" xmlns:r="http://schemas.openxmlformats.org/officeDocument/2006/relationships" xmlns:p="http://schemas.openxmlformats.org/presentationml/2006/main">
   <p:cSld>
     <p:spTree>
       <p:nvGrpSpPr>
@@ -3604,7 +3608,14 @@
         <p:cNvGrpSpPr/>
         <p:nvPr/>
       </p:nvGrpSpPr>
-      <p:grpSpPr/>
+      <p:grpSpPr>
+        <a:xfrm>
+          <a:off x="0" y="0"/>
+          <a:ext cx="0" cy="0"/>
+          <a:chOff x="0" y="0"/>
+          <a:chExt cx="0" cy="0"/>
+        </a:xfrm>
+      </p:grpSpPr>
       <p:sp>
         <p:nvSpPr>
           <p:cNvPr id="2" name="Rectangle 1"/>
@@ -3645,6 +3656,7 @@
           <a:lstStyle/>
           <a:p>
             <a:pPr algn="ctr"/>
+            <a:endParaRPr/>
           </a:p>
         </p:txBody>
       </p:sp>
@@ -3688,6 +3700,7 @@
           <a:lstStyle/>
           <a:p>
             <a:pPr algn="ctr"/>
+            <a:endParaRPr/>
           </a:p>
         </p:txBody>
       </p:sp>
@@ -3768,7 +3781,7 @@
           <a:lstStyle/>
           <a:p>
             <a:pPr>
-              <a:defRPr b="1" sz="2000">
+              <a:defRPr sz="2000" b="1">
                 <a:solidFill>
                   <a:srgbClr val="F8FAFC"/>
                 </a:solidFill>
@@ -3830,11 +3843,11 @@
           </a:fontRef>
         </p:style>
         <p:txBody>
-          <a:bodyPr rtlCol="0" anchor="ctr" lIns="228600" tIns="228600" wrap="square"/>
+          <a:bodyPr wrap="square" lIns="228600" tIns="228600" rtlCol="0" anchor="ctr"/>
           <a:lstStyle/>
           <a:p>
             <a:pPr algn="ctr">
-              <a:defRPr b="1" sz="1300">
+              <a:defRPr sz="1300" b="1">
                 <a:solidFill>
                   <a:srgbClr val="EF4444"/>
                 </a:solidFill>
@@ -3932,11 +3945,11 @@
           </a:fontRef>
         </p:style>
         <p:txBody>
-          <a:bodyPr rtlCol="0" anchor="ctr" lIns="228600" tIns="228600" wrap="square"/>
+          <a:bodyPr wrap="square" lIns="228600" tIns="228600" rtlCol="0" anchor="ctr"/>
           <a:lstStyle/>
           <a:p>
             <a:pPr algn="ctr">
-              <a:defRPr b="1" sz="1300">
+              <a:defRPr sz="1300" b="1">
                 <a:solidFill>
                   <a:srgbClr val="06B6D4"/>
                 </a:solidFill>
@@ -3967,7 +3980,7 @@
               </a:defRPr>
             </a:pPr>
             <a:r>
-              <a:t>• Semantic Vector: OpenStreetMap (OSM) vector boundaries (industrial, farmland, forest).</a:t>
+              <a:t>• Semantic Vector: OSM boundaries + ESA WorldCover land-cover class (industrial, farmland, forest).</a:t>
             </a:r>
           </a:p>
           <a:p>
@@ -4034,11 +4047,11 @@
           </a:fontRef>
         </p:style>
         <p:txBody>
-          <a:bodyPr rtlCol="0" anchor="ctr" lIns="228600" tIns="228600" wrap="square"/>
+          <a:bodyPr wrap="square" lIns="228600" tIns="228600" rtlCol="0" anchor="ctr"/>
           <a:lstStyle/>
           <a:p>
             <a:pPr algn="ctr">
-              <a:defRPr b="1" sz="1300">
+              <a:defRPr sz="1300" b="1">
                 <a:solidFill>
                   <a:srgbClr val="F97316"/>
                 </a:solidFill>
@@ -4107,7 +4120,7 @@
 </file>
 
 <file path=ppt/slides/slide3.xml><?xml version="1.0" encoding="utf-8"?>
-<p:sld xmlns:a="http://schemas.openxmlformats.org/drawingml/2006/main" xmlns:p="http://schemas.openxmlformats.org/presentationml/2006/main" xmlns:r="http://schemas.openxmlformats.org/officeDocument/2006/relationships">
+<p:sld xmlns:a="http://schemas.openxmlformats.org/drawingml/2006/main" xmlns:r="http://schemas.openxmlformats.org/officeDocument/2006/relationships" xmlns:p="http://schemas.openxmlformats.org/presentationml/2006/main">
   <p:cSld>
     <p:spTree>
       <p:nvGrpSpPr>
@@ -4115,7 +4128,14 @@
         <p:cNvGrpSpPr/>
         <p:nvPr/>
       </p:nvGrpSpPr>
-      <p:grpSpPr/>
+      <p:grpSpPr>
+        <a:xfrm>
+          <a:off x="0" y="0"/>
+          <a:ext cx="0" cy="0"/>
+          <a:chOff x="0" y="0"/>
+          <a:chExt cx="0" cy="0"/>
+        </a:xfrm>
+      </p:grpSpPr>
       <p:sp>
         <p:nvSpPr>
           <p:cNvPr id="2" name="Rectangle 1"/>
@@ -4156,6 +4176,7 @@
           <a:lstStyle/>
           <a:p>
             <a:pPr algn="ctr"/>
+            <a:endParaRPr/>
           </a:p>
         </p:txBody>
       </p:sp>
@@ -4199,6 +4220,7 @@
           <a:lstStyle/>
           <a:p>
             <a:pPr algn="ctr"/>
+            <a:endParaRPr/>
           </a:p>
         </p:txBody>
       </p:sp>
@@ -4279,7 +4301,7 @@
           <a:lstStyle/>
           <a:p>
             <a:pPr>
-              <a:defRPr b="1" sz="2000">
+              <a:defRPr sz="2000" b="1">
                 <a:solidFill>
                   <a:srgbClr val="F8FAFC"/>
                 </a:solidFill>
@@ -4341,11 +4363,11 @@
           </a:fontRef>
         </p:style>
         <p:txBody>
-          <a:bodyPr rtlCol="0" anchor="ctr" lIns="182880" tIns="182880" wrap="square"/>
+          <a:bodyPr wrap="square" lIns="182880" tIns="182880" rtlCol="0" anchor="ctr"/>
           <a:lstStyle/>
           <a:p>
             <a:pPr algn="ctr">
-              <a:defRPr b="1" sz="1200">
+              <a:defRPr sz="1200" b="1">
                 <a:solidFill>
                   <a:srgbClr val="06B6D4"/>
                 </a:solidFill>
@@ -4455,11 +4477,11 @@
           </a:fontRef>
         </p:style>
         <p:txBody>
-          <a:bodyPr rtlCol="0" anchor="ctr" lIns="182880" tIns="182880" wrap="square"/>
+          <a:bodyPr wrap="square" lIns="182880" tIns="182880" rtlCol="0" anchor="ctr"/>
           <a:lstStyle/>
           <a:p>
             <a:pPr algn="ctr">
-              <a:defRPr b="1" sz="1200">
+              <a:defRPr sz="1200" b="1">
                 <a:solidFill>
                   <a:srgbClr val="A855F7"/>
                 </a:solidFill>
@@ -4478,6 +4500,9 @@
               </a:defRPr>
             </a:pPr>
             <a:r>
+              <a:rPr>
+                <a:solidFill/>
+              </a:rPr>
               <a:t>• OpenStreetMap Overpass API</a:t>
             </a:r>
           </a:p>
@@ -4515,6 +4540,14 @@
             </a:pPr>
             <a:r>
               <a:t>• Computes Haversine distance to registered plants</a:t>
+            </a:r>
+          </a:p>
+          <a:p>
+            <a:pPr>
+              <a:defRPr/>
+            </a:pPr>
+            <a:r>
+              <a:t>• ESA WorldCover 10m Land-Cover Class per Hotspot</a:t>
             </a:r>
           </a:p>
         </p:txBody>
@@ -4557,11 +4590,11 @@
           </a:fontRef>
         </p:style>
         <p:txBody>
-          <a:bodyPr rtlCol="0" anchor="ctr" lIns="182880" tIns="182880" wrap="square"/>
+          <a:bodyPr wrap="square" lIns="182880" tIns="182880" rtlCol="0" anchor="ctr"/>
           <a:lstStyle/>
           <a:p>
             <a:pPr algn="ctr">
-              <a:defRPr b="1" sz="1200">
+              <a:defRPr sz="1200" b="1">
                 <a:solidFill>
                   <a:srgbClr val="F97316"/>
                 </a:solidFill>
@@ -4659,11 +4692,11 @@
           </a:fontRef>
         </p:style>
         <p:txBody>
-          <a:bodyPr rtlCol="0" anchor="ctr" lIns="182880" tIns="182880" wrap="square"/>
+          <a:bodyPr wrap="square" lIns="182880" tIns="182880" rtlCol="0" anchor="ctr"/>
           <a:lstStyle/>
           <a:p>
             <a:pPr algn="ctr">
-              <a:defRPr b="1" sz="1200">
+              <a:defRPr sz="1200" b="1">
                 <a:solidFill>
                   <a:srgbClr val="10B981"/>
                 </a:solidFill>
@@ -4798,7 +4831,7 @@
 </file>
 
 <file path=ppt/slides/slide4.xml><?xml version="1.0" encoding="utf-8"?>
-<p:sld xmlns:a="http://schemas.openxmlformats.org/drawingml/2006/main" xmlns:p="http://schemas.openxmlformats.org/presentationml/2006/main" xmlns:r="http://schemas.openxmlformats.org/officeDocument/2006/relationships">
+<p:sld xmlns:a="http://schemas.openxmlformats.org/drawingml/2006/main" xmlns:r="http://schemas.openxmlformats.org/officeDocument/2006/relationships" xmlns:p="http://schemas.openxmlformats.org/presentationml/2006/main">
   <p:cSld>
     <p:spTree>
       <p:nvGrpSpPr>
@@ -4806,7 +4839,14 @@
         <p:cNvGrpSpPr/>
         <p:nvPr/>
       </p:nvGrpSpPr>
-      <p:grpSpPr/>
+      <p:grpSpPr>
+        <a:xfrm>
+          <a:off x="0" y="0"/>
+          <a:ext cx="0" cy="0"/>
+          <a:chOff x="0" y="0"/>
+          <a:chExt cx="0" cy="0"/>
+        </a:xfrm>
+      </p:grpSpPr>
       <p:sp>
         <p:nvSpPr>
           <p:cNvPr id="2" name="Rectangle 1"/>
@@ -4847,6 +4887,7 @@
           <a:lstStyle/>
           <a:p>
             <a:pPr algn="ctr"/>
+            <a:endParaRPr/>
           </a:p>
         </p:txBody>
       </p:sp>
@@ -4890,6 +4931,7 @@
           <a:lstStyle/>
           <a:p>
             <a:pPr algn="ctr"/>
+            <a:endParaRPr/>
           </a:p>
         </p:txBody>
       </p:sp>
@@ -4970,7 +5012,7 @@
           <a:lstStyle/>
           <a:p>
             <a:pPr>
-              <a:defRPr b="1" sz="2000">
+              <a:defRPr sz="2000" b="1">
                 <a:solidFill>
                   <a:srgbClr val="F8FAFC"/>
                 </a:solidFill>
@@ -5032,11 +5074,11 @@
           </a:fontRef>
         </p:style>
         <p:txBody>
-          <a:bodyPr rtlCol="0" anchor="ctr" lIns="182880" tIns="182880" wrap="square"/>
+          <a:bodyPr wrap="square" lIns="182880" tIns="182880" rtlCol="0" anchor="ctr"/>
           <a:lstStyle/>
           <a:p>
             <a:pPr algn="ctr">
-              <a:defRPr b="1" sz="1100">
+              <a:defRPr sz="1100" b="1">
                 <a:solidFill>
                   <a:srgbClr val="06B6D4"/>
                 </a:solidFill>
@@ -5110,11 +5152,11 @@
           </a:fontRef>
         </p:style>
         <p:txBody>
-          <a:bodyPr rtlCol="0" anchor="ctr" lIns="182880" tIns="182880" wrap="square"/>
+          <a:bodyPr wrap="square" lIns="182880" tIns="182880" rtlCol="0" anchor="ctr"/>
           <a:lstStyle/>
           <a:p>
             <a:pPr algn="ctr">
-              <a:defRPr b="1" sz="1100">
+              <a:defRPr sz="1100" b="1">
                 <a:solidFill>
                   <a:srgbClr val="10B981"/>
                 </a:solidFill>
@@ -5188,11 +5230,11 @@
           </a:fontRef>
         </p:style>
         <p:txBody>
-          <a:bodyPr rtlCol="0" anchor="ctr" lIns="182880" tIns="182880" wrap="square"/>
+          <a:bodyPr wrap="square" lIns="182880" tIns="182880" rtlCol="0" anchor="ctr"/>
           <a:lstStyle/>
           <a:p>
             <a:pPr algn="ctr">
-              <a:defRPr b="1" sz="1100">
+              <a:defRPr sz="1100" b="1">
                 <a:solidFill>
                   <a:srgbClr val="F97316"/>
                 </a:solidFill>
@@ -5266,11 +5308,11 @@
           </a:fontRef>
         </p:style>
         <p:txBody>
-          <a:bodyPr rtlCol="0" anchor="ctr" lIns="182880" tIns="182880" wrap="square"/>
+          <a:bodyPr wrap="square" lIns="182880" tIns="182880" rtlCol="0" anchor="ctr"/>
           <a:lstStyle/>
           <a:p>
             <a:pPr algn="ctr">
-              <a:defRPr b="1" sz="1100">
+              <a:defRPr sz="1100" b="1">
                 <a:solidFill>
                   <a:srgbClr val="A855F7"/>
                 </a:solidFill>
@@ -5315,7 +5357,7 @@
 </file>
 
 <file path=ppt/slides/slide5.xml><?xml version="1.0" encoding="utf-8"?>
-<p:sld xmlns:a="http://schemas.openxmlformats.org/drawingml/2006/main" xmlns:p="http://schemas.openxmlformats.org/presentationml/2006/main" xmlns:r="http://schemas.openxmlformats.org/officeDocument/2006/relationships">
+<p:sld xmlns:a="http://schemas.openxmlformats.org/drawingml/2006/main" xmlns:r="http://schemas.openxmlformats.org/officeDocument/2006/relationships" xmlns:p="http://schemas.openxmlformats.org/presentationml/2006/main">
   <p:cSld>
     <p:spTree>
       <p:nvGrpSpPr>
@@ -5323,7 +5365,14 @@
         <p:cNvGrpSpPr/>
         <p:nvPr/>
       </p:nvGrpSpPr>
-      <p:grpSpPr/>
+      <p:grpSpPr>
+        <a:xfrm>
+          <a:off x="0" y="0"/>
+          <a:ext cx="0" cy="0"/>
+          <a:chOff x="0" y="0"/>
+          <a:chExt cx="0" cy="0"/>
+        </a:xfrm>
+      </p:grpSpPr>
       <p:sp>
         <p:nvSpPr>
           <p:cNvPr id="2" name="Rectangle 1"/>
@@ -5364,6 +5413,7 @@
           <a:lstStyle/>
           <a:p>
             <a:pPr algn="ctr"/>
+            <a:endParaRPr/>
           </a:p>
         </p:txBody>
       </p:sp>
@@ -5407,6 +5457,7 @@
           <a:lstStyle/>
           <a:p>
             <a:pPr algn="ctr"/>
+            <a:endParaRPr/>
           </a:p>
         </p:txBody>
       </p:sp>
@@ -5487,7 +5538,7 @@
           <a:lstStyle/>
           <a:p>
             <a:pPr>
-              <a:defRPr b="1" sz="2000">
+              <a:defRPr sz="2000" b="1">
                 <a:solidFill>
                   <a:srgbClr val="F8FAFC"/>
                 </a:solidFill>
@@ -5549,11 +5600,11 @@
           </a:fontRef>
         </p:style>
         <p:txBody>
-          <a:bodyPr rtlCol="0" anchor="ctr" lIns="182880" tIns="182880" wrap="square"/>
+          <a:bodyPr wrap="square" lIns="182880" tIns="182880" rtlCol="0" anchor="ctr"/>
           <a:lstStyle/>
           <a:p>
             <a:pPr algn="ctr">
-              <a:defRPr b="1" sz="1150">
+              <a:defRPr sz="1150" b="1">
                 <a:solidFill>
                   <a:srgbClr val="F97316"/>
                 </a:solidFill>
@@ -5639,11 +5690,11 @@
           </a:fontRef>
         </p:style>
         <p:txBody>
-          <a:bodyPr rtlCol="0" anchor="ctr" lIns="182880" tIns="182880" wrap="square"/>
+          <a:bodyPr wrap="square" lIns="182880" tIns="182880" rtlCol="0" anchor="ctr"/>
           <a:lstStyle/>
           <a:p>
             <a:pPr algn="ctr">
-              <a:defRPr b="1" sz="1150">
+              <a:defRPr sz="1150" b="1">
                 <a:solidFill>
                   <a:srgbClr val="06B6D4"/>
                 </a:solidFill>
@@ -5729,11 +5780,11 @@
           </a:fontRef>
         </p:style>
         <p:txBody>
-          <a:bodyPr rtlCol="0" anchor="ctr" lIns="182880" tIns="182880" wrap="square"/>
+          <a:bodyPr wrap="square" lIns="182880" tIns="182880" rtlCol="0" anchor="ctr"/>
           <a:lstStyle/>
           <a:p>
             <a:pPr algn="ctr">
-              <a:defRPr b="1" sz="1150">
+              <a:defRPr sz="1150" b="1">
                 <a:solidFill>
                   <a:srgbClr val="10B981"/>
                 </a:solidFill>
@@ -5819,11 +5870,11 @@
           </a:fontRef>
         </p:style>
         <p:txBody>
-          <a:bodyPr rtlCol="0" anchor="ctr" lIns="182880" tIns="182880" wrap="square"/>
+          <a:bodyPr wrap="square" lIns="182880" tIns="182880" rtlCol="0" anchor="ctr"/>
           <a:lstStyle/>
           <a:p>
             <a:pPr algn="ctr">
-              <a:defRPr b="1" sz="1150">
+              <a:defRPr sz="1150" b="1">
                 <a:solidFill>
                   <a:srgbClr val="A855F7"/>
                 </a:solidFill>
@@ -5880,7 +5931,7 @@
 </file>
 
 <file path=ppt/slides/slide6.xml><?xml version="1.0" encoding="utf-8"?>
-<p:sld xmlns:a="http://schemas.openxmlformats.org/drawingml/2006/main" xmlns:p="http://schemas.openxmlformats.org/presentationml/2006/main" xmlns:r="http://schemas.openxmlformats.org/officeDocument/2006/relationships">
+<p:sld xmlns:a="http://schemas.openxmlformats.org/drawingml/2006/main" xmlns:r="http://schemas.openxmlformats.org/officeDocument/2006/relationships" xmlns:p="http://schemas.openxmlformats.org/presentationml/2006/main">
   <p:cSld>
     <p:spTree>
       <p:nvGrpSpPr>
@@ -5888,7 +5939,14 @@
         <p:cNvGrpSpPr/>
         <p:nvPr/>
       </p:nvGrpSpPr>
-      <p:grpSpPr/>
+      <p:grpSpPr>
+        <a:xfrm>
+          <a:off x="0" y="0"/>
+          <a:ext cx="0" cy="0"/>
+          <a:chOff x="0" y="0"/>
+          <a:chExt cx="0" cy="0"/>
+        </a:xfrm>
+      </p:grpSpPr>
       <p:sp>
         <p:nvSpPr>
           <p:cNvPr id="2" name="Rectangle 1"/>
@@ -5929,6 +5987,7 @@
           <a:lstStyle/>
           <a:p>
             <a:pPr algn="ctr"/>
+            <a:endParaRPr/>
           </a:p>
         </p:txBody>
       </p:sp>
@@ -5972,6 +6031,7 @@
           <a:lstStyle/>
           <a:p>
             <a:pPr algn="ctr"/>
+            <a:endParaRPr/>
           </a:p>
         </p:txBody>
       </p:sp>
@@ -6052,7 +6112,7 @@
           <a:lstStyle/>
           <a:p>
             <a:pPr>
-              <a:defRPr b="1" sz="2000">
+              <a:defRPr sz="2000" b="1">
                 <a:solidFill>
                   <a:srgbClr val="F8FAFC"/>
                 </a:solidFill>
@@ -6114,11 +6174,11 @@
           </a:fontRef>
         </p:style>
         <p:txBody>
-          <a:bodyPr rtlCol="0" anchor="ctr" lIns="228600" tIns="228600" wrap="square"/>
+          <a:bodyPr wrap="square" lIns="228600" tIns="228600" rtlCol="0" anchor="ctr"/>
           <a:lstStyle/>
           <a:p>
             <a:pPr algn="ctr">
-              <a:defRPr b="1" sz="1200">
+              <a:defRPr sz="1200" b="1">
                 <a:solidFill>
                   <a:srgbClr val="10B981"/>
                 </a:solidFill>
@@ -6130,7 +6190,7 @@
           </a:p>
           <a:p>
             <a:pPr>
-              <a:defRPr b="1" sz="1000">
+              <a:defRPr sz="1000" b="1">
                 <a:solidFill>
                   <a:srgbClr val="F8FAFC"/>
                 </a:solidFill>
@@ -6154,7 +6214,7 @@
           </a:p>
           <a:p>
             <a:pPr>
-              <a:defRPr b="1" sz="1000">
+              <a:defRPr sz="1000" b="1">
                 <a:solidFill>
                   <a:srgbClr val="F8FAFC"/>
                 </a:solidFill>
@@ -6178,7 +6238,7 @@
           </a:p>
           <a:p>
             <a:pPr>
-              <a:defRPr b="1" sz="1000">
+              <a:defRPr sz="1000" b="1">
                 <a:solidFill>
                   <a:srgbClr val="F8FAFC"/>
                 </a:solidFill>
@@ -6202,7 +6262,7 @@
           </a:p>
           <a:p>
             <a:pPr>
-              <a:defRPr b="1" sz="1000">
+              <a:defRPr sz="1000" b="1">
                 <a:solidFill>
                   <a:srgbClr val="F8FAFC"/>
                 </a:solidFill>
@@ -6264,11 +6324,11 @@
           </a:fontRef>
         </p:style>
         <p:txBody>
-          <a:bodyPr rtlCol="0" anchor="ctr" lIns="228600" tIns="228600" wrap="square"/>
+          <a:bodyPr wrap="square" lIns="228600" tIns="228600" rtlCol="0" anchor="ctr"/>
           <a:lstStyle/>
           <a:p>
             <a:pPr algn="ctr">
-              <a:defRPr b="1" sz="1200">
+              <a:defRPr sz="1200" b="1">
                 <a:solidFill>
                   <a:srgbClr val="F59E0B"/>
                 </a:solidFill>
@@ -6280,7 +6340,7 @@
           </a:p>
           <a:p>
             <a:pPr>
-              <a:defRPr b="1" sz="1000">
+              <a:defRPr sz="1000" b="1">
                 <a:solidFill>
                   <a:srgbClr val="F8FAFC"/>
                 </a:solidFill>
@@ -6304,7 +6364,7 @@
           </a:p>
           <a:p>
             <a:pPr>
-              <a:defRPr b="1" sz="1000">
+              <a:defRPr sz="1000" b="1">
                 <a:solidFill>
                   <a:srgbClr val="F8FAFC"/>
                 </a:solidFill>
@@ -6328,7 +6388,7 @@
           </a:p>
           <a:p>
             <a:pPr>
-              <a:defRPr b="1" sz="1000">
+              <a:defRPr sz="1000" b="1">
                 <a:solidFill>
                   <a:srgbClr val="F8FAFC"/>
                 </a:solidFill>
@@ -6352,7 +6412,7 @@
           </a:p>
           <a:p>
             <a:pPr>
-              <a:defRPr b="1" sz="1000">
+              <a:defRPr sz="1000" b="1">
                 <a:solidFill>
                   <a:srgbClr val="F8FAFC"/>
                 </a:solidFill>
@@ -6385,7 +6445,7 @@
 </file>
 
 <file path=ppt/slides/slide7.xml><?xml version="1.0" encoding="utf-8"?>
-<p:sld xmlns:a="http://schemas.openxmlformats.org/drawingml/2006/main" xmlns:p="http://schemas.openxmlformats.org/presentationml/2006/main" xmlns:r="http://schemas.openxmlformats.org/officeDocument/2006/relationships">
+<p:sld xmlns:a="http://schemas.openxmlformats.org/drawingml/2006/main" xmlns:r="http://schemas.openxmlformats.org/officeDocument/2006/relationships" xmlns:p="http://schemas.openxmlformats.org/presentationml/2006/main">
   <p:cSld>
     <p:spTree>
       <p:nvGrpSpPr>
@@ -6393,7 +6453,14 @@
         <p:cNvGrpSpPr/>
         <p:nvPr/>
       </p:nvGrpSpPr>
-      <p:grpSpPr/>
+      <p:grpSpPr>
+        <a:xfrm>
+          <a:off x="0" y="0"/>
+          <a:ext cx="0" cy="0"/>
+          <a:chOff x="0" y="0"/>
+          <a:chExt cx="0" cy="0"/>
+        </a:xfrm>
+      </p:grpSpPr>
       <p:sp>
         <p:nvSpPr>
           <p:cNvPr id="2" name="Rectangle 1"/>
@@ -6434,6 +6501,7 @@
           <a:lstStyle/>
           <a:p>
             <a:pPr algn="ctr"/>
+            <a:endParaRPr/>
           </a:p>
         </p:txBody>
       </p:sp>
@@ -6477,6 +6545,7 @@
           <a:lstStyle/>
           <a:p>
             <a:pPr algn="ctr"/>
+            <a:endParaRPr/>
           </a:p>
         </p:txBody>
       </p:sp>
@@ -6557,7 +6626,7 @@
           <a:lstStyle/>
           <a:p>
             <a:pPr>
-              <a:defRPr b="1" sz="2000">
+              <a:defRPr sz="2000" b="1">
                 <a:solidFill>
                   <a:srgbClr val="F8FAFC"/>
                 </a:solidFill>
@@ -6589,7 +6658,7 @@
         </p:nvSpPr>
         <p:spPr>
           <a:xfrm>
-            <a:off x="731520" y="1645920"/>
+            <a:off x="689187" y="1645920"/>
             <a:ext cx="3383280" cy="4389120"/>
           </a:xfrm>
           <a:prstGeom prst="roundRect">
@@ -6619,11 +6688,11 @@
           </a:fontRef>
         </p:style>
         <p:txBody>
-          <a:bodyPr rtlCol="0" anchor="ctr" lIns="182880" tIns="182880" wrap="square"/>
+          <a:bodyPr wrap="square" lIns="182880" tIns="182880" rtlCol="0" anchor="ctr"/>
           <a:lstStyle/>
           <a:p>
             <a:pPr algn="ctr">
-              <a:defRPr b="1" sz="1200">
+              <a:defRPr sz="1200" b="1">
                 <a:solidFill>
                   <a:srgbClr val="10B981"/>
                 </a:solidFill>
@@ -6642,7 +6711,10 @@
               </a:defRPr>
             </a:pPr>
             <a:r>
-              <a:t>✔ Multi-Temporal Persistence Engine (60-day baseline)</a:t>
+              <a:rPr>
+                <a:solidFill/>
+              </a:rPr>
+              <a:t>✔ Live AI Classification Pipeline (FIRMS → OSM → Persistence → WorldCover)</a:t>
             </a:r>
           </a:p>
           <a:p>
@@ -6654,7 +6726,8 @@
               </a:defRPr>
             </a:pPr>
             <a:r>
-              <a:t>✔ NASA FIRMS VIIRS &amp; MODIS NRT Ingestion Core</a:t>
+              <a:rPr/>
+              <a:t>✔ 7-Class Taxonomy incl. Power Plants, Steel, Mining &amp; Clandestine</a:t>
             </a:r>
           </a:p>
           <a:p>
@@ -6666,7 +6739,8 @@
               </a:defRPr>
             </a:pPr>
             <a:r>
-              <a:t>✔ OpenStreetMap Semantic Boundary Correlation</a:t>
+              <a:rPr/>
+              <a:t>✔ Live GIS Overlay: Leaflet Map with Evidence Dossiers per Hotspot</a:t>
             </a:r>
           </a:p>
           <a:p>
@@ -6678,7 +6752,8 @@
               </a:defRPr>
             </a:pPr>
             <a:r>
-              <a:t>✔ 4 Real-World Indian Scenarios Tested &amp; Benchmarked</a:t>
+              <a:rPr/>
+              <a:t>✔ Incident Lifecycle State Machine with Agency Dispatch (Live API)</a:t>
             </a:r>
           </a:p>
           <a:p>
@@ -6690,7 +6765,8 @@
               </a:defRPr>
             </a:pPr>
             <a:r>
-              <a:t>✔ Interactive Geospatial SOC Dashboard with Satellite Toggle</a:t>
+              <a:rPr/>
+              <a:t>✔ Citizen Crowdsourced Reporting ↔ Command Cross-Check Loop</a:t>
             </a:r>
           </a:p>
           <a:p>
@@ -6702,7 +6778,8 @@
               </a:defRPr>
             </a:pPr>
             <a:r>
-              <a:t>✔ Automated GeoJSON &amp; Official PDF Dossier Export</a:t>
+              <a:rPr/>
+              <a:t>✔ Server-Side Persistence + NASA FIRMS Live-Key Integration</a:t>
             </a:r>
           </a:p>
         </p:txBody>
@@ -6715,7 +6792,7 @@
         </p:nvSpPr>
         <p:spPr>
           <a:xfrm>
-            <a:off x="3429000" y="1645920"/>
+            <a:off x="4072467" y="1645920"/>
             <a:ext cx="3383280" cy="4389120"/>
           </a:xfrm>
           <a:prstGeom prst="roundRect">
@@ -6745,11 +6822,11 @@
           </a:fontRef>
         </p:style>
         <p:txBody>
-          <a:bodyPr rtlCol="0" anchor="ctr" lIns="182880" tIns="182880" wrap="square"/>
+          <a:bodyPr wrap="square" lIns="182880" tIns="182880" rtlCol="0" anchor="ctr"/>
           <a:lstStyle/>
           <a:p>
             <a:pPr algn="ctr">
-              <a:defRPr b="1" sz="1200">
+              <a:defRPr sz="1200" b="1">
                 <a:solidFill>
                   <a:srgbClr val="06B6D4"/>
                 </a:solidFill>
@@ -6829,7 +6906,7 @@
         </p:nvSpPr>
         <p:spPr>
           <a:xfrm>
-            <a:off x="6126480" y="1645920"/>
+            <a:off x="7455747" y="1645920"/>
             <a:ext cx="3383280" cy="4389120"/>
           </a:xfrm>
           <a:prstGeom prst="roundRect">
@@ -6859,11 +6936,11 @@
           </a:fontRef>
         </p:style>
         <p:txBody>
-          <a:bodyPr rtlCol="0" anchor="ctr" lIns="182880" tIns="182880" wrap="square"/>
+          <a:bodyPr wrap="square" lIns="182880" tIns="182880" rtlCol="0" anchor="ctr"/>
           <a:lstStyle/>
           <a:p>
             <a:pPr algn="ctr">
-              <a:defRPr b="1" sz="1200">
+              <a:defRPr sz="1200" b="1">
                 <a:solidFill>
                   <a:srgbClr val="F97316"/>
                 </a:solidFill>

</xml_diff>